<commit_message>
Update project report and presentation with full technical detail and figures
Co-Authored-By: Yousef Abdulrahman <jolmera2003@gmail.com>
Co-Authored-By: Mohamed Roshdy <msh3rawy129@gmail.com>
Co-Authored-By: Basmala Hatem <basmala.hatem4@gmail.com>
</commit_message>
<xml_diff>
--- a/docs/presentation.pptx
+++ b/docs/presentation.pptx
@@ -5,16 +5,16 @@
     <p:sldMasterId id="2147483648" r:id="rId1"/>
   </p:sldMasterIdLst>
   <p:sldIdLst>
-    <p:sldId id="256" r:id="rId7"/>
-    <p:sldId id="257" r:id="rId8"/>
-    <p:sldId id="258" r:id="rId9"/>
-    <p:sldId id="259" r:id="rId10"/>
-    <p:sldId id="260" r:id="rId11"/>
-    <p:sldId id="261" r:id="rId12"/>
-    <p:sldId id="262" r:id="rId13"/>
-    <p:sldId id="263" r:id="rId14"/>
+    <p:sldId id="256" r:id="rId2"/>
+    <p:sldId id="257" r:id="rId3"/>
+    <p:sldId id="258" r:id="rId4"/>
+    <p:sldId id="259" r:id="rId5"/>
+    <p:sldId id="260" r:id="rId6"/>
+    <p:sldId id="261" r:id="rId7"/>
+    <p:sldId id="262" r:id="rId8"/>
+    <p:sldId id="263" r:id="rId9"/>
   </p:sldIdLst>
-  <p:sldSz cx="12188952" cy="6858000" type="screen4x3"/>
+  <p:sldSz cx="12188825" cy="6858000"/>
   <p:notesSz cx="6858000" cy="9144000"/>
   <p:defaultTextStyle>
     <a:defPPr>
@@ -111,6 +111,22 @@
       </a:defRPr>
     </a:lvl9pPr>
   </p:defaultTextStyle>
+  <p:extLst>
+    <p:ext uri="{EFAFB233-063F-42B5-8137-9DF3F51BA10A}">
+      <p15:sldGuideLst xmlns:p15="http://schemas.microsoft.com/office/powerpoint/2012/main">
+        <p15:guide id="1" orient="horz" pos="2160">
+          <p15:clr>
+            <a:srgbClr val="A4A3A4"/>
+          </p15:clr>
+        </p15:guide>
+        <p15:guide id="2" pos="2880">
+          <p15:clr>
+            <a:srgbClr val="A4A3A4"/>
+          </p15:clr>
+        </p15:guide>
+      </p15:sldGuideLst>
+    </p:ext>
+  </p:extLst>
 </p:presentation>
 </file>
 
@@ -295,7 +311,7 @@
           <a:p>
             <a:fld id="{5BCAD085-E8A6-8845-BD4E-CB4CCA059FC4}" type="datetimeFigureOut">
               <a:rPr lang="en-US" smtClean="0"/>
-              <a:t>1/27/13</a:t>
+              <a:t>5/31/2026</a:t>
             </a:fld>
             <a:endParaRPr lang="en-US"/>
           </a:p>
@@ -465,7 +481,7 @@
           <a:p>
             <a:fld id="{5BCAD085-E8A6-8845-BD4E-CB4CCA059FC4}" type="datetimeFigureOut">
               <a:rPr lang="en-US" smtClean="0"/>
-              <a:t>1/27/13</a:t>
+              <a:t>5/31/2026</a:t>
             </a:fld>
             <a:endParaRPr lang="en-US"/>
           </a:p>
@@ -645,7 +661,7 @@
           <a:p>
             <a:fld id="{5BCAD085-E8A6-8845-BD4E-CB4CCA059FC4}" type="datetimeFigureOut">
               <a:rPr lang="en-US" smtClean="0"/>
-              <a:t>1/27/13</a:t>
+              <a:t>5/31/2026</a:t>
             </a:fld>
             <a:endParaRPr lang="en-US"/>
           </a:p>
@@ -815,7 +831,7 @@
           <a:p>
             <a:fld id="{5BCAD085-E8A6-8845-BD4E-CB4CCA059FC4}" type="datetimeFigureOut">
               <a:rPr lang="en-US" smtClean="0"/>
-              <a:t>1/27/13</a:t>
+              <a:t>5/31/2026</a:t>
             </a:fld>
             <a:endParaRPr lang="en-US"/>
           </a:p>
@@ -1061,7 +1077,7 @@
           <a:p>
             <a:fld id="{5BCAD085-E8A6-8845-BD4E-CB4CCA059FC4}" type="datetimeFigureOut">
               <a:rPr lang="en-US" smtClean="0"/>
-              <a:t>1/27/13</a:t>
+              <a:t>5/31/2026</a:t>
             </a:fld>
             <a:endParaRPr lang="en-US"/>
           </a:p>
@@ -1349,7 +1365,7 @@
           <a:p>
             <a:fld id="{5BCAD085-E8A6-8845-BD4E-CB4CCA059FC4}" type="datetimeFigureOut">
               <a:rPr lang="en-US" smtClean="0"/>
-              <a:t>1/27/13</a:t>
+              <a:t>5/31/2026</a:t>
             </a:fld>
             <a:endParaRPr lang="en-US"/>
           </a:p>
@@ -1771,7 +1787,7 @@
           <a:p>
             <a:fld id="{5BCAD085-E8A6-8845-BD4E-CB4CCA059FC4}" type="datetimeFigureOut">
               <a:rPr lang="en-US" smtClean="0"/>
-              <a:t>1/27/13</a:t>
+              <a:t>5/31/2026</a:t>
             </a:fld>
             <a:endParaRPr lang="en-US"/>
           </a:p>
@@ -1889,7 +1905,7 @@
           <a:p>
             <a:fld id="{5BCAD085-E8A6-8845-BD4E-CB4CCA059FC4}" type="datetimeFigureOut">
               <a:rPr lang="en-US" smtClean="0"/>
-              <a:t>1/27/13</a:t>
+              <a:t>5/31/2026</a:t>
             </a:fld>
             <a:endParaRPr lang="en-US"/>
           </a:p>
@@ -1984,7 +2000,7 @@
           <a:p>
             <a:fld id="{5BCAD085-E8A6-8845-BD4E-CB4CCA059FC4}" type="datetimeFigureOut">
               <a:rPr lang="en-US" smtClean="0"/>
-              <a:t>1/27/13</a:t>
+              <a:t>5/31/2026</a:t>
             </a:fld>
             <a:endParaRPr lang="en-US"/>
           </a:p>
@@ -2261,7 +2277,7 @@
           <a:p>
             <a:fld id="{5BCAD085-E8A6-8845-BD4E-CB4CCA059FC4}" type="datetimeFigureOut">
               <a:rPr lang="en-US" smtClean="0"/>
-              <a:t>1/27/13</a:t>
+              <a:t>5/31/2026</a:t>
             </a:fld>
             <a:endParaRPr lang="en-US"/>
           </a:p>
@@ -2514,7 +2530,7 @@
           <a:p>
             <a:fld id="{5BCAD085-E8A6-8845-BD4E-CB4CCA059FC4}" type="datetimeFigureOut">
               <a:rPr lang="en-US" smtClean="0"/>
-              <a:t>1/27/13</a:t>
+              <a:t>5/31/2026</a:t>
             </a:fld>
             <a:endParaRPr lang="en-US"/>
           </a:p>
@@ -2727,7 +2743,7 @@
           <a:p>
             <a:fld id="{5BCAD085-E8A6-8845-BD4E-CB4CCA059FC4}" type="datetimeFigureOut">
               <a:rPr lang="en-US" smtClean="0"/>
-              <a:t>1/27/13</a:t>
+              <a:t>5/31/2026</a:t>
             </a:fld>
             <a:endParaRPr lang="en-US"/>
           </a:p>
@@ -3086,7 +3102,7 @@
 </file>
 
 <file path=ppt/slides/slide1.xml><?xml version="1.0" encoding="utf-8"?>
-<p:sld xmlns:a="http://schemas.openxmlformats.org/drawingml/2006/main" xmlns:p="http://schemas.openxmlformats.org/presentationml/2006/main" xmlns:r="http://schemas.openxmlformats.org/officeDocument/2006/relationships">
+<p:sld xmlns:a="http://schemas.openxmlformats.org/drawingml/2006/main" xmlns:r="http://schemas.openxmlformats.org/officeDocument/2006/relationships" xmlns:p="http://schemas.openxmlformats.org/presentationml/2006/main">
   <p:cSld>
     <p:spTree>
       <p:nvGrpSpPr>
@@ -3094,7 +3110,14 @@
         <p:cNvGrpSpPr/>
         <p:nvPr/>
       </p:nvGrpSpPr>
-      <p:grpSpPr/>
+      <p:grpSpPr>
+        <a:xfrm>
+          <a:off x="0" y="0"/>
+          <a:ext cx="0" cy="0"/>
+          <a:chOff x="0" y="0"/>
+          <a:chExt cx="0" cy="0"/>
+        </a:xfrm>
+      </p:grpSpPr>
       <p:sp>
         <p:nvSpPr>
           <p:cNvPr id="2" name="Rectangle 1"/>
@@ -3135,6 +3158,7 @@
           <a:lstStyle/>
           <a:p>
             <a:pPr algn="ctr"/>
+            <a:endParaRPr/>
           </a:p>
         </p:txBody>
       </p:sp>
@@ -3178,6 +3202,7 @@
           <a:lstStyle/>
           <a:p>
             <a:pPr algn="ctr"/>
+            <a:endParaRPr/>
           </a:p>
         </p:txBody>
       </p:sp>
@@ -3221,6 +3246,7 @@
           <a:lstStyle/>
           <a:p>
             <a:pPr algn="ctr"/>
+            <a:endParaRPr/>
           </a:p>
         </p:txBody>
       </p:sp>
@@ -3471,7 +3497,7 @@
 </file>
 
 <file path=ppt/slides/slide2.xml><?xml version="1.0" encoding="utf-8"?>
-<p:sld xmlns:a="http://schemas.openxmlformats.org/drawingml/2006/main" xmlns:p="http://schemas.openxmlformats.org/presentationml/2006/main" xmlns:r="http://schemas.openxmlformats.org/officeDocument/2006/relationships">
+<p:sld xmlns:a="http://schemas.openxmlformats.org/drawingml/2006/main" xmlns:r="http://schemas.openxmlformats.org/officeDocument/2006/relationships" xmlns:p="http://schemas.openxmlformats.org/presentationml/2006/main">
   <p:cSld>
     <p:spTree>
       <p:nvGrpSpPr>
@@ -3479,7 +3505,14 @@
         <p:cNvGrpSpPr/>
         <p:nvPr/>
       </p:nvGrpSpPr>
-      <p:grpSpPr/>
+      <p:grpSpPr>
+        <a:xfrm>
+          <a:off x="0" y="0"/>
+          <a:ext cx="0" cy="0"/>
+          <a:chOff x="0" y="0"/>
+          <a:chExt cx="0" cy="0"/>
+        </a:xfrm>
+      </p:grpSpPr>
       <p:sp>
         <p:nvSpPr>
           <p:cNvPr id="2" name="Rectangle 1"/>
@@ -3520,6 +3553,7 @@
           <a:lstStyle/>
           <a:p>
             <a:pPr algn="ctr"/>
+            <a:endParaRPr/>
           </a:p>
         </p:txBody>
       </p:sp>
@@ -3631,6 +3665,7 @@
           <a:lstStyle/>
           <a:p>
             <a:pPr algn="ctr"/>
+            <a:endParaRPr/>
           </a:p>
         </p:txBody>
       </p:sp>
@@ -3674,6 +3709,7 @@
           <a:lstStyle/>
           <a:p>
             <a:pPr algn="ctr"/>
+            <a:endParaRPr/>
           </a:p>
         </p:txBody>
       </p:sp>
@@ -3717,6 +3753,7 @@
           <a:lstStyle/>
           <a:p>
             <a:pPr algn="ctr"/>
+            <a:endParaRPr/>
           </a:p>
         </p:txBody>
       </p:sp>
@@ -3831,7 +3868,7 @@
         <p:spPr>
           <a:xfrm>
             <a:off x="365760" y="1828800"/>
-            <a:ext cx="5303520" cy="393192"/>
+            <a:ext cx="5633824" cy="323165"/>
           </a:xfrm>
           <a:prstGeom prst="rect">
             <a:avLst/>
@@ -3846,13 +3883,34 @@
           <a:p>
             <a:pPr algn="l"/>
             <a:r>
-              <a:rPr sz="1500" b="0" i="0">
+              <a:rPr sz="1500" b="0" i="0" dirty="0">
                 <a:solidFill>
                   <a:srgbClr val="333333"/>
                 </a:solidFill>
               </a:rPr>
-              <a:t>▸  Real-time image classification at the edge requires &lt; 50 ms latency</a:t>
-            </a:r>
+              <a:t>▸  Real-time image classification at the edge requires &lt; 50 </a:t>
+            </a:r>
+            <a:r>
+              <a:rPr sz="1500" b="0" i="0" dirty="0" err="1" smtClean="0">
+                <a:solidFill>
+                  <a:srgbClr val="333333"/>
+                </a:solidFill>
+              </a:rPr>
+              <a:t>ms</a:t>
+            </a:r>
+            <a:r>
+              <a:rPr sz="1500" b="0" i="0" dirty="0" smtClean="0">
+                <a:solidFill>
+                  <a:srgbClr val="333333"/>
+                </a:solidFill>
+              </a:rPr>
+              <a:t> latency</a:t>
+            </a:r>
+            <a:endParaRPr sz="1500" b="0" i="0" dirty="0">
+              <a:solidFill>
+                <a:srgbClr val="333333"/>
+              </a:solidFill>
+            </a:endParaRPr>
           </a:p>
         </p:txBody>
       </p:sp>
@@ -3865,7 +3923,7 @@
         <p:spPr>
           <a:xfrm>
             <a:off x="365760" y="2176272"/>
-            <a:ext cx="5303520" cy="393192"/>
+            <a:ext cx="6119016" cy="323165"/>
           </a:xfrm>
           <a:prstGeom prst="rect">
             <a:avLst/>
@@ -3880,7 +3938,7 @@
           <a:p>
             <a:pPr algn="l"/>
             <a:r>
-              <a:rPr sz="1500" b="0" i="0">
+              <a:rPr sz="1500" b="0" i="0" dirty="0">
                 <a:solidFill>
                   <a:srgbClr val="333333"/>
                 </a:solidFill>
@@ -3899,7 +3957,7 @@
         <p:spPr>
           <a:xfrm>
             <a:off x="365760" y="2523744"/>
-            <a:ext cx="5303520" cy="393192"/>
+            <a:ext cx="5727130" cy="323165"/>
           </a:xfrm>
           <a:prstGeom prst="rect">
             <a:avLst/>
@@ -3914,7 +3972,7 @@
           <a:p>
             <a:pPr algn="l"/>
             <a:r>
-              <a:rPr sz="1500" b="0" i="0">
+              <a:rPr sz="1500" b="0" i="0" dirty="0">
                 <a:solidFill>
                   <a:srgbClr val="333333"/>
                 </a:solidFill>
@@ -3933,7 +3991,7 @@
         <p:spPr>
           <a:xfrm>
             <a:off x="365760" y="2871216"/>
-            <a:ext cx="5303520" cy="393192"/>
+            <a:ext cx="5727130" cy="553998"/>
           </a:xfrm>
           <a:prstGeom prst="rect">
             <a:avLst/>
@@ -3948,7 +4006,7 @@
           <a:p>
             <a:pPr algn="l"/>
             <a:r>
-              <a:rPr sz="1500" b="0" i="0">
+              <a:rPr sz="1500" b="0" i="0" dirty="0">
                 <a:solidFill>
                   <a:srgbClr val="333333"/>
                 </a:solidFill>
@@ -4170,6 +4228,7 @@
           <a:lstStyle/>
           <a:p>
             <a:pPr algn="ctr"/>
+            <a:endParaRPr/>
           </a:p>
         </p:txBody>
       </p:sp>
@@ -4250,7 +4309,7 @@
 </file>
 
 <file path=ppt/slides/slide3.xml><?xml version="1.0" encoding="utf-8"?>
-<p:sld xmlns:a="http://schemas.openxmlformats.org/drawingml/2006/main" xmlns:p="http://schemas.openxmlformats.org/presentationml/2006/main" xmlns:r="http://schemas.openxmlformats.org/officeDocument/2006/relationships">
+<p:sld xmlns:a="http://schemas.openxmlformats.org/drawingml/2006/main" xmlns:r="http://schemas.openxmlformats.org/officeDocument/2006/relationships" xmlns:p="http://schemas.openxmlformats.org/presentationml/2006/main">
   <p:cSld>
     <p:spTree>
       <p:nvGrpSpPr>
@@ -4258,7 +4317,14 @@
         <p:cNvGrpSpPr/>
         <p:nvPr/>
       </p:nvGrpSpPr>
-      <p:grpSpPr/>
+      <p:grpSpPr>
+        <a:xfrm>
+          <a:off x="0" y="0"/>
+          <a:ext cx="0" cy="0"/>
+          <a:chOff x="0" y="0"/>
+          <a:chExt cx="0" cy="0"/>
+        </a:xfrm>
+      </p:grpSpPr>
       <p:sp>
         <p:nvSpPr>
           <p:cNvPr id="2" name="Rectangle 1"/>
@@ -4299,6 +4365,7 @@
           <a:lstStyle/>
           <a:p>
             <a:pPr algn="ctr"/>
+            <a:endParaRPr/>
           </a:p>
         </p:txBody>
       </p:sp>
@@ -4410,6 +4477,7 @@
           <a:lstStyle/>
           <a:p>
             <a:pPr algn="ctr"/>
+            <a:endParaRPr/>
           </a:p>
         </p:txBody>
       </p:sp>
@@ -4453,6 +4521,7 @@
           <a:lstStyle/>
           <a:p>
             <a:pPr algn="ctr"/>
+            <a:endParaRPr/>
           </a:p>
         </p:txBody>
       </p:sp>
@@ -4566,6 +4635,7 @@
           <a:lstStyle/>
           <a:p>
             <a:pPr algn="ctr"/>
+            <a:endParaRPr/>
           </a:p>
         </p:txBody>
       </p:sp>
@@ -4609,6 +4679,7 @@
           <a:lstStyle/>
           <a:p>
             <a:pPr algn="ctr"/>
+            <a:endParaRPr/>
           </a:p>
         </p:txBody>
       </p:sp>
@@ -4827,6 +4898,7 @@
           <a:lstStyle/>
           <a:p>
             <a:pPr algn="ctr"/>
+            <a:endParaRPr/>
           </a:p>
         </p:txBody>
       </p:sp>
@@ -4870,6 +4942,7 @@
           <a:lstStyle/>
           <a:p>
             <a:pPr algn="ctr"/>
+            <a:endParaRPr/>
           </a:p>
         </p:txBody>
       </p:sp>
@@ -5088,6 +5161,7 @@
           <a:lstStyle/>
           <a:p>
             <a:pPr algn="ctr"/>
+            <a:endParaRPr/>
           </a:p>
         </p:txBody>
       </p:sp>
@@ -5131,6 +5205,7 @@
           <a:lstStyle/>
           <a:p>
             <a:pPr algn="ctr"/>
+            <a:endParaRPr/>
           </a:p>
         </p:txBody>
       </p:sp>
@@ -5350,7 +5425,7 @@
 </file>
 
 <file path=ppt/slides/slide4.xml><?xml version="1.0" encoding="utf-8"?>
-<p:sld xmlns:a="http://schemas.openxmlformats.org/drawingml/2006/main" xmlns:p="http://schemas.openxmlformats.org/presentationml/2006/main" xmlns:r="http://schemas.openxmlformats.org/officeDocument/2006/relationships">
+<p:sld xmlns:a="http://schemas.openxmlformats.org/drawingml/2006/main" xmlns:r="http://schemas.openxmlformats.org/officeDocument/2006/relationships" xmlns:p="http://schemas.openxmlformats.org/presentationml/2006/main">
   <p:cSld>
     <p:spTree>
       <p:nvGrpSpPr>
@@ -5358,7 +5433,14 @@
         <p:cNvGrpSpPr/>
         <p:nvPr/>
       </p:nvGrpSpPr>
-      <p:grpSpPr/>
+      <p:grpSpPr>
+        <a:xfrm>
+          <a:off x="0" y="0"/>
+          <a:ext cx="0" cy="0"/>
+          <a:chOff x="0" y="0"/>
+          <a:chExt cx="0" cy="0"/>
+        </a:xfrm>
+      </p:grpSpPr>
       <p:sp>
         <p:nvSpPr>
           <p:cNvPr id="2" name="Rectangle 1"/>
@@ -5399,6 +5481,7 @@
           <a:lstStyle/>
           <a:p>
             <a:pPr algn="ctr"/>
+            <a:endParaRPr/>
           </a:p>
         </p:txBody>
       </p:sp>
@@ -5510,6 +5593,7 @@
           <a:lstStyle/>
           <a:p>
             <a:pPr algn="ctr"/>
+            <a:endParaRPr/>
           </a:p>
         </p:txBody>
       </p:sp>
@@ -5553,6 +5637,7 @@
           <a:lstStyle/>
           <a:p>
             <a:pPr algn="ctr"/>
+            <a:endParaRPr/>
           </a:p>
         </p:txBody>
       </p:sp>
@@ -6584,6 +6669,7 @@
           <a:lstStyle/>
           <a:p>
             <a:pPr algn="ctr"/>
+            <a:endParaRPr/>
           </a:p>
         </p:txBody>
       </p:sp>
@@ -6665,7 +6751,7 @@
 </file>
 
 <file path=ppt/slides/slide5.xml><?xml version="1.0" encoding="utf-8"?>
-<p:sld xmlns:a="http://schemas.openxmlformats.org/drawingml/2006/main" xmlns:p="http://schemas.openxmlformats.org/presentationml/2006/main" xmlns:r="http://schemas.openxmlformats.org/officeDocument/2006/relationships">
+<p:sld xmlns:a="http://schemas.openxmlformats.org/drawingml/2006/main" xmlns:r="http://schemas.openxmlformats.org/officeDocument/2006/relationships" xmlns:p="http://schemas.openxmlformats.org/presentationml/2006/main">
   <p:cSld>
     <p:spTree>
       <p:nvGrpSpPr>
@@ -6673,7 +6759,14 @@
         <p:cNvGrpSpPr/>
         <p:nvPr/>
       </p:nvGrpSpPr>
-      <p:grpSpPr/>
+      <p:grpSpPr>
+        <a:xfrm>
+          <a:off x="0" y="0"/>
+          <a:ext cx="0" cy="0"/>
+          <a:chOff x="0" y="0"/>
+          <a:chExt cx="0" cy="0"/>
+        </a:xfrm>
+      </p:grpSpPr>
       <p:sp>
         <p:nvSpPr>
           <p:cNvPr id="2" name="Rectangle 1"/>
@@ -6714,6 +6807,7 @@
           <a:lstStyle/>
           <a:p>
             <a:pPr algn="ctr"/>
+            <a:endParaRPr/>
           </a:p>
         </p:txBody>
       </p:sp>
@@ -6825,6 +6919,7 @@
           <a:lstStyle/>
           <a:p>
             <a:pPr algn="ctr"/>
+            <a:endParaRPr/>
           </a:p>
         </p:txBody>
       </p:sp>
@@ -6868,6 +6963,7 @@
           <a:lstStyle/>
           <a:p>
             <a:pPr algn="ctr"/>
+            <a:endParaRPr/>
           </a:p>
         </p:txBody>
       </p:sp>
@@ -6981,6 +7077,7 @@
           <a:lstStyle/>
           <a:p>
             <a:pPr algn="ctr"/>
+            <a:endParaRPr/>
           </a:p>
         </p:txBody>
       </p:sp>
@@ -7164,6 +7261,7 @@
           <a:lstStyle/>
           <a:p>
             <a:pPr algn="ctr"/>
+            <a:endParaRPr/>
           </a:p>
         </p:txBody>
       </p:sp>
@@ -7346,6 +7444,7 @@
           <a:lstStyle/>
           <a:p>
             <a:pPr algn="ctr"/>
+            <a:endParaRPr/>
           </a:p>
         </p:txBody>
       </p:sp>
@@ -7528,6 +7627,7 @@
           <a:lstStyle/>
           <a:p>
             <a:pPr algn="ctr"/>
+            <a:endParaRPr/>
           </a:p>
         </p:txBody>
       </p:sp>
@@ -7710,6 +7810,7 @@
           <a:lstStyle/>
           <a:p>
             <a:pPr algn="ctr"/>
+            <a:endParaRPr/>
           </a:p>
         </p:txBody>
       </p:sp>
@@ -7891,6 +7992,7 @@
           <a:lstStyle/>
           <a:p>
             <a:pPr algn="ctr"/>
+            <a:endParaRPr/>
           </a:p>
         </p:txBody>
       </p:sp>
@@ -8039,7 +8141,7 @@
 </file>
 
 <file path=ppt/slides/slide6.xml><?xml version="1.0" encoding="utf-8"?>
-<p:sld xmlns:a="http://schemas.openxmlformats.org/drawingml/2006/main" xmlns:p="http://schemas.openxmlformats.org/presentationml/2006/main" xmlns:r="http://schemas.openxmlformats.org/officeDocument/2006/relationships">
+<p:sld xmlns:a="http://schemas.openxmlformats.org/drawingml/2006/main" xmlns:r="http://schemas.openxmlformats.org/officeDocument/2006/relationships" xmlns:p="http://schemas.openxmlformats.org/presentationml/2006/main">
   <p:cSld>
     <p:spTree>
       <p:nvGrpSpPr>
@@ -8047,7 +8149,14 @@
         <p:cNvGrpSpPr/>
         <p:nvPr/>
       </p:nvGrpSpPr>
-      <p:grpSpPr/>
+      <p:grpSpPr>
+        <a:xfrm>
+          <a:off x="0" y="0"/>
+          <a:ext cx="0" cy="0"/>
+          <a:chOff x="0" y="0"/>
+          <a:chExt cx="0" cy="0"/>
+        </a:xfrm>
+      </p:grpSpPr>
       <p:sp>
         <p:nvSpPr>
           <p:cNvPr id="2" name="Rectangle 1"/>
@@ -8088,6 +8197,7 @@
           <a:lstStyle/>
           <a:p>
             <a:pPr algn="ctr"/>
+            <a:endParaRPr/>
           </a:p>
         </p:txBody>
       </p:sp>
@@ -8199,6 +8309,7 @@
           <a:lstStyle/>
           <a:p>
             <a:pPr algn="ctr"/>
+            <a:endParaRPr/>
           </a:p>
         </p:txBody>
       </p:sp>
@@ -8242,6 +8353,7 @@
           <a:lstStyle/>
           <a:p>
             <a:pPr algn="ctr"/>
+            <a:endParaRPr/>
           </a:p>
         </p:txBody>
       </p:sp>
@@ -8321,8 +8433,8 @@
         </p:nvSpPr>
         <p:spPr>
           <a:xfrm>
-            <a:off x="365760" y="1463040"/>
-            <a:ext cx="2377440" cy="1005840"/>
+            <a:off x="-1" y="1463040"/>
+            <a:ext cx="2313305" cy="1005840"/>
           </a:xfrm>
           <a:prstGeom prst="rect">
             <a:avLst/>
@@ -8355,6 +8467,7 @@
           <a:lstStyle/>
           <a:p>
             <a:pPr algn="ctr"/>
+            <a:endParaRPr/>
           </a:p>
         </p:txBody>
       </p:sp>
@@ -8366,7 +8479,7 @@
         </p:nvSpPr>
         <p:spPr>
           <a:xfrm>
-            <a:off x="365760" y="1508760"/>
+            <a:off x="-64135" y="1508760"/>
             <a:ext cx="2377440" cy="594360"/>
           </a:xfrm>
           <a:prstGeom prst="rect">
@@ -8400,7 +8513,7 @@
         </p:nvSpPr>
         <p:spPr>
           <a:xfrm>
-            <a:off x="365760" y="2084832"/>
+            <a:off x="-64135" y="2084832"/>
             <a:ext cx="2377440" cy="347472"/>
           </a:xfrm>
           <a:prstGeom prst="rect">
@@ -8434,7 +8547,7 @@
         </p:nvSpPr>
         <p:spPr>
           <a:xfrm>
-            <a:off x="2834640" y="1463040"/>
+            <a:off x="2404745" y="1463040"/>
             <a:ext cx="2377440" cy="1005840"/>
           </a:xfrm>
           <a:prstGeom prst="rect">
@@ -8468,6 +8581,7 @@
           <a:lstStyle/>
           <a:p>
             <a:pPr algn="ctr"/>
+            <a:endParaRPr/>
           </a:p>
         </p:txBody>
       </p:sp>
@@ -8479,7 +8593,7 @@
         </p:nvSpPr>
         <p:spPr>
           <a:xfrm>
-            <a:off x="2834640" y="1508760"/>
+            <a:off x="2404745" y="1508760"/>
             <a:ext cx="2377440" cy="594360"/>
           </a:xfrm>
           <a:prstGeom prst="rect">
@@ -8513,7 +8627,7 @@
         </p:nvSpPr>
         <p:spPr>
           <a:xfrm>
-            <a:off x="2834640" y="2084832"/>
+            <a:off x="2404745" y="2084832"/>
             <a:ext cx="2377440" cy="347472"/>
           </a:xfrm>
           <a:prstGeom prst="rect">
@@ -8547,7 +8661,7 @@
         </p:nvSpPr>
         <p:spPr>
           <a:xfrm>
-            <a:off x="5303520" y="1463040"/>
+            <a:off x="4873625" y="1463040"/>
             <a:ext cx="2377440" cy="1005840"/>
           </a:xfrm>
           <a:prstGeom prst="rect">
@@ -8581,6 +8695,7 @@
           <a:lstStyle/>
           <a:p>
             <a:pPr algn="ctr"/>
+            <a:endParaRPr/>
           </a:p>
         </p:txBody>
       </p:sp>
@@ -8592,7 +8707,7 @@
         </p:nvSpPr>
         <p:spPr>
           <a:xfrm>
-            <a:off x="5303520" y="1508760"/>
+            <a:off x="4873625" y="1508760"/>
             <a:ext cx="2377440" cy="594360"/>
           </a:xfrm>
           <a:prstGeom prst="rect">
@@ -8626,7 +8741,7 @@
         </p:nvSpPr>
         <p:spPr>
           <a:xfrm>
-            <a:off x="5303520" y="2084832"/>
+            <a:off x="4873625" y="2084832"/>
             <a:ext cx="2377440" cy="347472"/>
           </a:xfrm>
           <a:prstGeom prst="rect">
@@ -8660,7 +8775,7 @@
         </p:nvSpPr>
         <p:spPr>
           <a:xfrm>
-            <a:off x="7772400" y="1463040"/>
+            <a:off x="7342505" y="1463040"/>
             <a:ext cx="2377440" cy="1005840"/>
           </a:xfrm>
           <a:prstGeom prst="rect">
@@ -8694,6 +8809,7 @@
           <a:lstStyle/>
           <a:p>
             <a:pPr algn="ctr"/>
+            <a:endParaRPr/>
           </a:p>
         </p:txBody>
       </p:sp>
@@ -8705,7 +8821,7 @@
         </p:nvSpPr>
         <p:spPr>
           <a:xfrm>
-            <a:off x="7772400" y="1508760"/>
+            <a:off x="7342505" y="1508760"/>
             <a:ext cx="2377440" cy="594360"/>
           </a:xfrm>
           <a:prstGeom prst="rect">
@@ -8739,7 +8855,7 @@
         </p:nvSpPr>
         <p:spPr>
           <a:xfrm>
-            <a:off x="7772400" y="2084832"/>
+            <a:off x="7342505" y="2084832"/>
             <a:ext cx="2377440" cy="347472"/>
           </a:xfrm>
           <a:prstGeom prst="rect">
@@ -8773,7 +8889,7 @@
         </p:nvSpPr>
         <p:spPr>
           <a:xfrm>
-            <a:off x="10241280" y="1463040"/>
+            <a:off x="9811385" y="1463040"/>
             <a:ext cx="2377440" cy="1005840"/>
           </a:xfrm>
           <a:prstGeom prst="rect">
@@ -8807,6 +8923,7 @@
           <a:lstStyle/>
           <a:p>
             <a:pPr algn="ctr"/>
+            <a:endParaRPr/>
           </a:p>
         </p:txBody>
       </p:sp>
@@ -8818,7 +8935,7 @@
         </p:nvSpPr>
         <p:spPr>
           <a:xfrm>
-            <a:off x="10241280" y="1508760"/>
+            <a:off x="9811385" y="1508760"/>
             <a:ext cx="2377440" cy="594360"/>
           </a:xfrm>
           <a:prstGeom prst="rect">
@@ -8852,7 +8969,7 @@
         </p:nvSpPr>
         <p:spPr>
           <a:xfrm>
-            <a:off x="10241280" y="2084832"/>
+            <a:off x="9811385" y="2084832"/>
             <a:ext cx="2377440" cy="347472"/>
           </a:xfrm>
           <a:prstGeom prst="rect">
@@ -8920,6 +9037,7 @@
           <a:lstStyle/>
           <a:p>
             <a:pPr algn="ctr"/>
+            <a:endParaRPr/>
           </a:p>
         </p:txBody>
       </p:sp>
@@ -9679,6 +9797,7 @@
           <a:lstStyle/>
           <a:p>
             <a:pPr algn="ctr"/>
+            <a:endParaRPr/>
           </a:p>
         </p:txBody>
       </p:sp>
@@ -9759,7 +9878,7 @@
 </file>
 
 <file path=ppt/slides/slide7.xml><?xml version="1.0" encoding="utf-8"?>
-<p:sld xmlns:a="http://schemas.openxmlformats.org/drawingml/2006/main" xmlns:p="http://schemas.openxmlformats.org/presentationml/2006/main" xmlns:r="http://schemas.openxmlformats.org/officeDocument/2006/relationships">
+<p:sld xmlns:a="http://schemas.openxmlformats.org/drawingml/2006/main" xmlns:r="http://schemas.openxmlformats.org/officeDocument/2006/relationships" xmlns:p="http://schemas.openxmlformats.org/presentationml/2006/main">
   <p:cSld>
     <p:spTree>
       <p:nvGrpSpPr>
@@ -9767,7 +9886,14 @@
         <p:cNvGrpSpPr/>
         <p:nvPr/>
       </p:nvGrpSpPr>
-      <p:grpSpPr/>
+      <p:grpSpPr>
+        <a:xfrm>
+          <a:off x="0" y="0"/>
+          <a:ext cx="0" cy="0"/>
+          <a:chOff x="0" y="0"/>
+          <a:chExt cx="0" cy="0"/>
+        </a:xfrm>
+      </p:grpSpPr>
       <p:sp>
         <p:nvSpPr>
           <p:cNvPr id="2" name="Rectangle 1"/>
@@ -9808,6 +9934,7 @@
           <a:lstStyle/>
           <a:p>
             <a:pPr algn="ctr"/>
+            <a:endParaRPr/>
           </a:p>
         </p:txBody>
       </p:sp>
@@ -9919,6 +10046,7 @@
           <a:lstStyle/>
           <a:p>
             <a:pPr algn="ctr"/>
+            <a:endParaRPr/>
           </a:p>
         </p:txBody>
       </p:sp>
@@ -9962,6 +10090,7 @@
           <a:lstStyle/>
           <a:p>
             <a:pPr algn="ctr"/>
+            <a:endParaRPr/>
           </a:p>
         </p:txBody>
       </p:sp>
@@ -10075,6 +10204,7 @@
           <a:lstStyle/>
           <a:p>
             <a:pPr algn="ctr"/>
+            <a:endParaRPr/>
           </a:p>
         </p:txBody>
       </p:sp>
@@ -10118,6 +10248,7 @@
           <a:lstStyle/>
           <a:p>
             <a:pPr algn="ctr"/>
+            <a:endParaRPr/>
           </a:p>
         </p:txBody>
       </p:sp>
@@ -10267,6 +10398,7 @@
           <a:lstStyle/>
           <a:p>
             <a:pPr algn="ctr"/>
+            <a:endParaRPr/>
           </a:p>
         </p:txBody>
       </p:sp>
@@ -10310,6 +10442,7 @@
           <a:lstStyle/>
           <a:p>
             <a:pPr algn="ctr"/>
+            <a:endParaRPr/>
           </a:p>
         </p:txBody>
       </p:sp>
@@ -10459,6 +10592,7 @@
           <a:lstStyle/>
           <a:p>
             <a:pPr algn="ctr"/>
+            <a:endParaRPr/>
           </a:p>
         </p:txBody>
       </p:sp>
@@ -10502,6 +10636,7 @@
           <a:lstStyle/>
           <a:p>
             <a:pPr algn="ctr"/>
+            <a:endParaRPr/>
           </a:p>
         </p:txBody>
       </p:sp>
@@ -10651,6 +10786,7 @@
           <a:lstStyle/>
           <a:p>
             <a:pPr algn="ctr"/>
+            <a:endParaRPr/>
           </a:p>
         </p:txBody>
       </p:sp>
@@ -10694,6 +10830,7 @@
           <a:lstStyle/>
           <a:p>
             <a:pPr algn="ctr"/>
+            <a:endParaRPr/>
           </a:p>
         </p:txBody>
       </p:sp>
@@ -10843,6 +10980,7 @@
           <a:lstStyle/>
           <a:p>
             <a:pPr algn="ctr"/>
+            <a:endParaRPr/>
           </a:p>
         </p:txBody>
       </p:sp>
@@ -10957,7 +11095,7 @@
 </file>
 
 <file path=ppt/slides/slide8.xml><?xml version="1.0" encoding="utf-8"?>
-<p:sld xmlns:a="http://schemas.openxmlformats.org/drawingml/2006/main" xmlns:p="http://schemas.openxmlformats.org/presentationml/2006/main" xmlns:r="http://schemas.openxmlformats.org/officeDocument/2006/relationships">
+<p:sld xmlns:a="http://schemas.openxmlformats.org/drawingml/2006/main" xmlns:r="http://schemas.openxmlformats.org/officeDocument/2006/relationships" xmlns:p="http://schemas.openxmlformats.org/presentationml/2006/main">
   <p:cSld>
     <p:spTree>
       <p:nvGrpSpPr>
@@ -10965,7 +11103,14 @@
         <p:cNvGrpSpPr/>
         <p:nvPr/>
       </p:nvGrpSpPr>
-      <p:grpSpPr/>
+      <p:grpSpPr>
+        <a:xfrm>
+          <a:off x="0" y="0"/>
+          <a:ext cx="0" cy="0"/>
+          <a:chOff x="0" y="0"/>
+          <a:chExt cx="0" cy="0"/>
+        </a:xfrm>
+      </p:grpSpPr>
       <p:sp>
         <p:nvSpPr>
           <p:cNvPr id="2" name="Rectangle 1"/>
@@ -11006,6 +11151,7 @@
           <a:lstStyle/>
           <a:p>
             <a:pPr algn="ctr"/>
+            <a:endParaRPr/>
           </a:p>
         </p:txBody>
       </p:sp>
@@ -11083,6 +11229,7 @@
           <a:lstStyle/>
           <a:p>
             <a:pPr algn="ctr"/>
+            <a:endParaRPr/>
           </a:p>
         </p:txBody>
       </p:sp>
@@ -11126,6 +11273,7 @@
           <a:lstStyle/>
           <a:p>
             <a:pPr algn="ctr"/>
+            <a:endParaRPr/>
           </a:p>
         </p:txBody>
       </p:sp>
@@ -11240,7 +11388,7 @@
         <p:spPr>
           <a:xfrm>
             <a:off x="365760" y="1801368"/>
-            <a:ext cx="5394960" cy="393192"/>
+            <a:ext cx="6035040" cy="307777"/>
           </a:xfrm>
           <a:prstGeom prst="rect">
             <a:avLst/>
@@ -11255,12 +11403,28 @@
           <a:p>
             <a:pPr algn="l"/>
             <a:r>
-              <a:rPr sz="1400" b="0" i="0">
+              <a:rPr sz="1400" b="0" i="0" dirty="0">
                 <a:solidFill>
                   <a:srgbClr val="333333"/>
                 </a:solidFill>
               </a:rPr>
-              <a:t>▸  Complete RTL implementation of ShuffleNet V2 — timing closed at 100 MHz</a:t>
+              <a:t>▸  Complete RTL implementation of </a:t>
+            </a:r>
+            <a:r>
+              <a:rPr sz="1400" b="0" i="0" dirty="0" err="1">
+                <a:solidFill>
+                  <a:srgbClr val="333333"/>
+                </a:solidFill>
+              </a:rPr>
+              <a:t>ShuffleNet</a:t>
+            </a:r>
+            <a:r>
+              <a:rPr sz="1400" b="0" i="0" dirty="0">
+                <a:solidFill>
+                  <a:srgbClr val="333333"/>
+                </a:solidFill>
+              </a:rPr>
+              <a:t> V2 — timing closed at 100 MHz</a:t>
             </a:r>
           </a:p>
         </p:txBody>
@@ -11611,6 +11775,7 @@
           <a:lstStyle/>
           <a:p>
             <a:pPr algn="ctr"/>
+            <a:endParaRPr/>
           </a:p>
         </p:txBody>
       </p:sp>

</xml_diff>